<commit_message>
docs: add one-line speaker notes to every slide of the English decks
Each slide now carries a one-sentence speaker note (PowerPoint notes pane,
not shown on the slide). Implemented via a NOTES array + a mkSlide() helper
that attaches the note on slide creation; note order matches slide order.
Counts verified: 23/23, 26/26, 29/29, 8/8.

Co-Authored-By: Claude Opus 4.8 <noreply@anthropic.com>
</commit_message>
<xml_diff>
--- a/docs/slides/L1L2_DeepDive_EN.pptx
+++ b/docs/slides/L1L2_DeepDive_EN.pptx
@@ -509,7 +509,7 @@
           <a:p>
             <a:r>
               <a:rPr lang="en-US" dirty="0"/>
-              <a:t/>
+              <a:t>Frame the talk: L1 is about safely USING tools, L2 about safely BUILDING them — both start by taking crash-prone tool calling out of the evolution loop.</a:t>
             </a:r>
             <a:endParaRPr lang="en-US" dirty="0"/>
           </a:p>
@@ -597,7 +597,7 @@
           <a:p>
             <a:r>
               <a:rPr lang="en-US" dirty="0"/>
-              <a:t/>
+              <a:t>The one shared trick: freeze a safety boundary and let the content evolve freely, so the worst case is always graceful degradation, not a crash.</a:t>
             </a:r>
             <a:endParaRPr lang="en-US" dirty="0"/>
           </a:p>
@@ -685,7 +685,7 @@
           <a:p>
             <a:r>
               <a:rPr lang="en-US" dirty="0"/>
-              <a:t/>
+              <a:t>Before, the LLM called tools and could crash; after, a deterministic executor fetches the data before the crew runs, so no agent calls tools anymore.</a:t>
             </a:r>
             <a:endParaRPr lang="en-US" dirty="0"/>
           </a:p>
@@ -773,7 +773,7 @@
           <a:p>
             <a:r>
               <a:rPr lang="en-US" dirty="0"/>
-              <a:t/>
+              <a:t>Even with a frozen whitelist, evolution still chooses which queries, in what order, and how to sample — the same alphabet writes infinitely many sentences.</a:t>
             </a:r>
             <a:endParaRPr lang="en-US" dirty="0"/>
           </a:p>
@@ -861,7 +861,7 @@
           <a:p>
             <a:r>
               <a:rPr lang="en-US" dirty="0"/>
-              <a:t/>
+              <a:t>Walk the policy from declaration through the executor to the final score, and note the clamp that makes any bad policy degrade instead of crash.</a:t>
             </a:r>
             <a:endParaRPr lang="en-US" dirty="0"/>
           </a:p>
@@ -949,7 +949,7 @@
           <a:p>
             <a:r>
               <a:rPr lang="en-US" dirty="0"/>
-              <a:t/>
+              <a:t>Show the four gates an evolved tool must pass — AST scan, signature, sandbox trial, wrap — and that ReadOnlyKit limits it to read-only data.</a:t>
             </a:r>
             <a:endParaRPr lang="en-US" dirty="0"/>
           </a:p>
@@ -1037,7 +1037,7 @@
           <a:p>
             <a:r>
               <a:rPr lang="en-US" dirty="0"/>
-              <a:t/>
+              <a:t>The agent decides to call a tool by reading its docstring, so discoverability is under evolutionary pressure; broken tools are silently dropped.</a:t>
             </a:r>
             <a:endParaRPr lang="en-US" dirty="0"/>
           </a:p>
@@ -1125,7 +1125,7 @@
           <a:p>
             <a:r>
               <a:rPr lang="en-US" dirty="0"/>
-              <a:t/>
+              <a:t>Tie it together: L1 composes new sentences, L2 coins new words, both bounded by the dataset — freeze the boundary, free the content.</a:t>
             </a:r>
             <a:endParaRPr lang="en-US" dirty="0"/>
           </a:p>
@@ -1500,7 +1500,7 @@
       </p:grpSpPr>
       <p:sp>
         <p:nvSpPr>
-          <p:cNvPr id="2" name="Shape 0"/>
+          <p:cNvPr id="3" name="Shape 0"/>
           <p:cNvSpPr/>
           <p:nvPr/>
         </p:nvSpPr>
@@ -1520,7 +1520,7 @@
       </p:sp>
       <p:sp>
         <p:nvSpPr>
-          <p:cNvPr id="3" name="Text 1"/>
+          <p:cNvPr id="4" name="Text 1"/>
           <p:cNvSpPr/>
           <p:nvPr/>
         </p:nvSpPr>
@@ -1559,7 +1559,7 @@
       </p:sp>
       <p:sp>
         <p:nvSpPr>
-          <p:cNvPr id="4" name="Text 2"/>
+          <p:cNvPr id="5" name="Text 2"/>
           <p:cNvSpPr/>
           <p:nvPr/>
         </p:nvSpPr>
@@ -1598,7 +1598,7 @@
       </p:sp>
       <p:sp>
         <p:nvSpPr>
-          <p:cNvPr id="5" name="Text 3"/>
+          <p:cNvPr id="6" name="Text 3"/>
           <p:cNvSpPr/>
           <p:nvPr/>
         </p:nvSpPr>
@@ -1637,7 +1637,7 @@
       </p:sp>
       <p:sp>
         <p:nvSpPr>
-          <p:cNvPr id="6" name="Text 4"/>
+          <p:cNvPr id="7" name="Text 4"/>
           <p:cNvSpPr/>
           <p:nvPr/>
         </p:nvSpPr>
@@ -1676,7 +1676,7 @@
       </p:sp>
       <p:sp>
         <p:nvSpPr>
-          <p:cNvPr id="7" name="Shape 5"/>
+          <p:cNvPr id="8" name="Shape 5"/>
           <p:cNvSpPr/>
           <p:nvPr/>
         </p:nvSpPr>
@@ -1698,7 +1698,7 @@
       </p:sp>
       <p:sp>
         <p:nvSpPr>
-          <p:cNvPr id="8" name="Text 6"/>
+          <p:cNvPr id="9" name="Text 6"/>
           <p:cNvSpPr/>
           <p:nvPr/>
         </p:nvSpPr>
@@ -1737,7 +1737,7 @@
       </p:sp>
       <p:sp>
         <p:nvSpPr>
-          <p:cNvPr id="9" name="Shape 7"/>
+          <p:cNvPr id="10" name="Shape 7"/>
           <p:cNvSpPr/>
           <p:nvPr/>
         </p:nvSpPr>
@@ -1759,7 +1759,7 @@
       </p:sp>
       <p:sp>
         <p:nvSpPr>
-          <p:cNvPr id="10" name="Text 8"/>
+          <p:cNvPr id="11" name="Text 8"/>
           <p:cNvSpPr/>
           <p:nvPr/>
         </p:nvSpPr>
@@ -1798,7 +1798,7 @@
       </p:sp>
       <p:sp>
         <p:nvSpPr>
-          <p:cNvPr id="11" name="Text 9"/>
+          <p:cNvPr id="12" name="Text 9"/>
           <p:cNvSpPr/>
           <p:nvPr/>
         </p:nvSpPr>
@@ -1974,7 +1974,7 @@
       </p:grpSpPr>
       <p:sp>
         <p:nvSpPr>
-          <p:cNvPr id="2" name="Shape 0"/>
+          <p:cNvPr id="3" name="Shape 0"/>
           <p:cNvSpPr/>
           <p:nvPr/>
         </p:nvSpPr>
@@ -1994,7 +1994,7 @@
       </p:sp>
       <p:sp>
         <p:nvSpPr>
-          <p:cNvPr id="3" name="Text 1"/>
+          <p:cNvPr id="4" name="Text 1"/>
           <p:cNvSpPr/>
           <p:nvPr/>
         </p:nvSpPr>
@@ -2033,7 +2033,7 @@
       </p:sp>
       <p:sp>
         <p:nvSpPr>
-          <p:cNvPr id="4" name="Text 2"/>
+          <p:cNvPr id="5" name="Text 2"/>
           <p:cNvSpPr/>
           <p:nvPr/>
         </p:nvSpPr>
@@ -2916,7 +2916,7 @@
       </p:graphicFrame>
       <p:sp>
         <p:nvSpPr>
-          <p:cNvPr id="6" name="Shape 3"/>
+          <p:cNvPr id="7" name="Shape 3"/>
           <p:cNvSpPr/>
           <p:nvPr/>
         </p:nvSpPr>
@@ -2948,7 +2948,7 @@
       </p:sp>
       <p:sp>
         <p:nvSpPr>
-          <p:cNvPr id="7" name="Text 4"/>
+          <p:cNvPr id="8" name="Text 4"/>
           <p:cNvSpPr/>
           <p:nvPr/>
         </p:nvSpPr>
@@ -3007,7 +3007,7 @@
       </p:sp>
       <p:sp>
         <p:nvSpPr>
-          <p:cNvPr id="8" name="Text 5"/>
+          <p:cNvPr id="9" name="Text 5"/>
           <p:cNvSpPr/>
           <p:nvPr/>
         </p:nvSpPr>
@@ -3197,7 +3197,7 @@
       </p:grpSpPr>
       <p:sp>
         <p:nvSpPr>
-          <p:cNvPr id="2" name="Shape 0"/>
+          <p:cNvPr id="3" name="Shape 0"/>
           <p:cNvSpPr/>
           <p:nvPr/>
         </p:nvSpPr>
@@ -3217,7 +3217,7 @@
       </p:sp>
       <p:sp>
         <p:nvSpPr>
-          <p:cNvPr id="3" name="Text 1"/>
+          <p:cNvPr id="4" name="Text 1"/>
           <p:cNvSpPr/>
           <p:nvPr/>
         </p:nvSpPr>
@@ -3256,7 +3256,7 @@
       </p:sp>
       <p:sp>
         <p:nvSpPr>
-          <p:cNvPr id="4" name="Text 2"/>
+          <p:cNvPr id="5" name="Text 2"/>
           <p:cNvSpPr/>
           <p:nvPr/>
         </p:nvSpPr>
@@ -3295,7 +3295,7 @@
       </p:sp>
       <p:sp>
         <p:nvSpPr>
-          <p:cNvPr id="5" name="Shape 3"/>
+          <p:cNvPr id="6" name="Shape 3"/>
           <p:cNvSpPr/>
           <p:nvPr/>
         </p:nvSpPr>
@@ -3327,7 +3327,7 @@
       </p:sp>
       <p:sp>
         <p:nvSpPr>
-          <p:cNvPr id="6" name="Text 4"/>
+          <p:cNvPr id="7" name="Text 4"/>
           <p:cNvSpPr/>
           <p:nvPr/>
         </p:nvSpPr>
@@ -3366,7 +3366,7 @@
       </p:sp>
       <p:sp>
         <p:nvSpPr>
-          <p:cNvPr id="7" name="Text 5"/>
+          <p:cNvPr id="8" name="Text 5"/>
           <p:cNvSpPr/>
           <p:nvPr/>
         </p:nvSpPr>
@@ -3442,7 +3442,7 @@
       </p:sp>
       <p:sp>
         <p:nvSpPr>
-          <p:cNvPr id="8" name="Text 6"/>
+          <p:cNvPr id="9" name="Text 6"/>
           <p:cNvSpPr/>
           <p:nvPr/>
         </p:nvSpPr>
@@ -3481,7 +3481,7 @@
       </p:sp>
       <p:sp>
         <p:nvSpPr>
-          <p:cNvPr id="9" name="Shape 7"/>
+          <p:cNvPr id="10" name="Shape 7"/>
           <p:cNvSpPr/>
           <p:nvPr/>
         </p:nvSpPr>
@@ -3513,7 +3513,7 @@
       </p:sp>
       <p:sp>
         <p:nvSpPr>
-          <p:cNvPr id="10" name="Text 8"/>
+          <p:cNvPr id="11" name="Text 8"/>
           <p:cNvSpPr/>
           <p:nvPr/>
         </p:nvSpPr>
@@ -3552,7 +3552,7 @@
       </p:sp>
       <p:sp>
         <p:nvSpPr>
-          <p:cNvPr id="11" name="Text 9"/>
+          <p:cNvPr id="12" name="Text 9"/>
           <p:cNvSpPr/>
           <p:nvPr/>
         </p:nvSpPr>
@@ -3648,7 +3648,7 @@
       </p:sp>
       <p:sp>
         <p:nvSpPr>
-          <p:cNvPr id="12" name="Text 10"/>
+          <p:cNvPr id="13" name="Text 10"/>
           <p:cNvSpPr/>
           <p:nvPr/>
         </p:nvSpPr>
@@ -3687,7 +3687,7 @@
       </p:sp>
       <p:sp>
         <p:nvSpPr>
-          <p:cNvPr id="13" name="Text 11"/>
+          <p:cNvPr id="14" name="Text 11"/>
           <p:cNvSpPr/>
           <p:nvPr/>
         </p:nvSpPr>
@@ -3726,7 +3726,7 @@
       </p:sp>
       <p:sp>
         <p:nvSpPr>
-          <p:cNvPr id="14" name="Text 12"/>
+          <p:cNvPr id="15" name="Text 12"/>
           <p:cNvSpPr/>
           <p:nvPr/>
         </p:nvSpPr>
@@ -3867,7 +3867,7 @@
       </p:grpSpPr>
       <p:sp>
         <p:nvSpPr>
-          <p:cNvPr id="2" name="Shape 0"/>
+          <p:cNvPr id="3" name="Shape 0"/>
           <p:cNvSpPr/>
           <p:nvPr/>
         </p:nvSpPr>
@@ -3887,7 +3887,7 @@
       </p:sp>
       <p:sp>
         <p:nvSpPr>
-          <p:cNvPr id="3" name="Text 1"/>
+          <p:cNvPr id="4" name="Text 1"/>
           <p:cNvSpPr/>
           <p:nvPr/>
         </p:nvSpPr>
@@ -3926,7 +3926,7 @@
       </p:sp>
       <p:sp>
         <p:nvSpPr>
-          <p:cNvPr id="4" name="Text 2"/>
+          <p:cNvPr id="5" name="Text 2"/>
           <p:cNvSpPr/>
           <p:nvPr/>
         </p:nvSpPr>
@@ -3965,7 +3965,7 @@
       </p:sp>
       <p:sp>
         <p:nvSpPr>
-          <p:cNvPr id="5" name="Text 3"/>
+          <p:cNvPr id="6" name="Text 3"/>
           <p:cNvSpPr/>
           <p:nvPr/>
         </p:nvSpPr>
@@ -4004,7 +4004,7 @@
       </p:sp>
       <p:sp>
         <p:nvSpPr>
-          <p:cNvPr id="6" name="Shape 4"/>
+          <p:cNvPr id="7" name="Shape 4"/>
           <p:cNvSpPr/>
           <p:nvPr/>
         </p:nvSpPr>
@@ -4036,7 +4036,7 @@
       </p:sp>
       <p:sp>
         <p:nvSpPr>
-          <p:cNvPr id="7" name="Text 5"/>
+          <p:cNvPr id="8" name="Text 5"/>
           <p:cNvSpPr/>
           <p:nvPr/>
         </p:nvSpPr>
@@ -4092,7 +4092,7 @@
       </p:sp>
       <p:sp>
         <p:nvSpPr>
-          <p:cNvPr id="8" name="Shape 6"/>
+          <p:cNvPr id="9" name="Shape 6"/>
           <p:cNvSpPr/>
           <p:nvPr/>
         </p:nvSpPr>
@@ -4124,7 +4124,7 @@
       </p:sp>
       <p:sp>
         <p:nvSpPr>
-          <p:cNvPr id="9" name="Text 7"/>
+          <p:cNvPr id="10" name="Text 7"/>
           <p:cNvSpPr/>
           <p:nvPr/>
         </p:nvSpPr>
@@ -4180,7 +4180,7 @@
       </p:sp>
       <p:sp>
         <p:nvSpPr>
-          <p:cNvPr id="10" name="Text 8"/>
+          <p:cNvPr id="11" name="Text 8"/>
           <p:cNvSpPr/>
           <p:nvPr/>
         </p:nvSpPr>
@@ -4219,7 +4219,7 @@
       </p:sp>
       <p:sp>
         <p:nvSpPr>
-          <p:cNvPr id="11" name="Shape 9"/>
+          <p:cNvPr id="12" name="Shape 9"/>
           <p:cNvSpPr/>
           <p:nvPr/>
         </p:nvSpPr>
@@ -4251,7 +4251,7 @@
       </p:sp>
       <p:sp>
         <p:nvSpPr>
-          <p:cNvPr id="12" name="Text 10"/>
+          <p:cNvPr id="13" name="Text 10"/>
           <p:cNvSpPr/>
           <p:nvPr/>
         </p:nvSpPr>
@@ -4333,7 +4333,7 @@
       </p:sp>
       <p:sp>
         <p:nvSpPr>
-          <p:cNvPr id="13" name="Shape 11"/>
+          <p:cNvPr id="14" name="Shape 11"/>
           <p:cNvSpPr/>
           <p:nvPr/>
         </p:nvSpPr>
@@ -4365,7 +4365,7 @@
       </p:sp>
       <p:sp>
         <p:nvSpPr>
-          <p:cNvPr id="14" name="Text 12"/>
+          <p:cNvPr id="15" name="Text 12"/>
           <p:cNvSpPr/>
           <p:nvPr/>
         </p:nvSpPr>
@@ -4447,7 +4447,7 @@
       </p:sp>
       <p:sp>
         <p:nvSpPr>
-          <p:cNvPr id="15" name="Text 13"/>
+          <p:cNvPr id="16" name="Text 13"/>
           <p:cNvSpPr/>
           <p:nvPr/>
         </p:nvSpPr>
@@ -4486,7 +4486,7 @@
       </p:sp>
       <p:sp>
         <p:nvSpPr>
-          <p:cNvPr id="16" name="Text 14"/>
+          <p:cNvPr id="17" name="Text 14"/>
           <p:cNvSpPr/>
           <p:nvPr/>
         </p:nvSpPr>
@@ -4662,7 +4662,7 @@
       </p:grpSpPr>
       <p:sp>
         <p:nvSpPr>
-          <p:cNvPr id="2" name="Shape 0"/>
+          <p:cNvPr id="3" name="Shape 0"/>
           <p:cNvSpPr/>
           <p:nvPr/>
         </p:nvSpPr>
@@ -4682,7 +4682,7 @@
       </p:sp>
       <p:sp>
         <p:nvSpPr>
-          <p:cNvPr id="3" name="Text 1"/>
+          <p:cNvPr id="4" name="Text 1"/>
           <p:cNvSpPr/>
           <p:nvPr/>
         </p:nvSpPr>
@@ -4721,7 +4721,7 @@
       </p:sp>
       <p:sp>
         <p:nvSpPr>
-          <p:cNvPr id="4" name="Text 2"/>
+          <p:cNvPr id="5" name="Text 2"/>
           <p:cNvSpPr/>
           <p:nvPr/>
         </p:nvSpPr>
@@ -4760,7 +4760,7 @@
       </p:sp>
       <p:sp>
         <p:nvSpPr>
-          <p:cNvPr id="5" name="Shape 3"/>
+          <p:cNvPr id="6" name="Shape 3"/>
           <p:cNvSpPr/>
           <p:nvPr/>
         </p:nvSpPr>
@@ -4792,7 +4792,7 @@
       </p:sp>
       <p:sp>
         <p:nvSpPr>
-          <p:cNvPr id="6" name="Shape 4"/>
+          <p:cNvPr id="7" name="Shape 4"/>
           <p:cNvSpPr/>
           <p:nvPr/>
         </p:nvSpPr>
@@ -4812,7 +4812,7 @@
       </p:sp>
       <p:sp>
         <p:nvSpPr>
-          <p:cNvPr id="7" name="Text 5"/>
+          <p:cNvPr id="8" name="Text 5"/>
           <p:cNvSpPr/>
           <p:nvPr/>
         </p:nvSpPr>
@@ -4874,7 +4874,7 @@
       </p:sp>
       <p:sp>
         <p:nvSpPr>
-          <p:cNvPr id="8" name="Text 6"/>
+          <p:cNvPr id="9" name="Text 6"/>
           <p:cNvSpPr/>
           <p:nvPr/>
         </p:nvSpPr>
@@ -4913,7 +4913,7 @@
       </p:sp>
       <p:sp>
         <p:nvSpPr>
-          <p:cNvPr id="9" name="Shape 7"/>
+          <p:cNvPr id="10" name="Shape 7"/>
           <p:cNvSpPr/>
           <p:nvPr/>
         </p:nvSpPr>
@@ -4945,7 +4945,7 @@
       </p:sp>
       <p:sp>
         <p:nvSpPr>
-          <p:cNvPr id="10" name="Shape 8"/>
+          <p:cNvPr id="11" name="Shape 8"/>
           <p:cNvSpPr/>
           <p:nvPr/>
         </p:nvSpPr>
@@ -4965,7 +4965,7 @@
       </p:sp>
       <p:sp>
         <p:nvSpPr>
-          <p:cNvPr id="11" name="Text 9"/>
+          <p:cNvPr id="12" name="Text 9"/>
           <p:cNvSpPr/>
           <p:nvPr/>
         </p:nvSpPr>
@@ -5027,7 +5027,7 @@
       </p:sp>
       <p:sp>
         <p:nvSpPr>
-          <p:cNvPr id="12" name="Text 10"/>
+          <p:cNvPr id="13" name="Text 10"/>
           <p:cNvSpPr/>
           <p:nvPr/>
         </p:nvSpPr>
@@ -5066,7 +5066,7 @@
       </p:sp>
       <p:sp>
         <p:nvSpPr>
-          <p:cNvPr id="13" name="Shape 11"/>
+          <p:cNvPr id="14" name="Shape 11"/>
           <p:cNvSpPr/>
           <p:nvPr/>
         </p:nvSpPr>
@@ -5098,7 +5098,7 @@
       </p:sp>
       <p:sp>
         <p:nvSpPr>
-          <p:cNvPr id="14" name="Shape 12"/>
+          <p:cNvPr id="15" name="Shape 12"/>
           <p:cNvSpPr/>
           <p:nvPr/>
         </p:nvSpPr>
@@ -5118,7 +5118,7 @@
       </p:sp>
       <p:sp>
         <p:nvSpPr>
-          <p:cNvPr id="15" name="Text 13"/>
+          <p:cNvPr id="16" name="Text 13"/>
           <p:cNvSpPr/>
           <p:nvPr/>
         </p:nvSpPr>
@@ -5160,7 +5160,7 @@
       </p:sp>
       <p:sp>
         <p:nvSpPr>
-          <p:cNvPr id="16" name="Text 14"/>
+          <p:cNvPr id="17" name="Text 14"/>
           <p:cNvSpPr/>
           <p:nvPr/>
         </p:nvSpPr>
@@ -5199,7 +5199,7 @@
       </p:sp>
       <p:sp>
         <p:nvSpPr>
-          <p:cNvPr id="17" name="Shape 15"/>
+          <p:cNvPr id="18" name="Shape 15"/>
           <p:cNvSpPr/>
           <p:nvPr/>
         </p:nvSpPr>
@@ -5231,7 +5231,7 @@
       </p:sp>
       <p:sp>
         <p:nvSpPr>
-          <p:cNvPr id="18" name="Shape 16"/>
+          <p:cNvPr id="19" name="Shape 16"/>
           <p:cNvSpPr/>
           <p:nvPr/>
         </p:nvSpPr>
@@ -5251,7 +5251,7 @@
       </p:sp>
       <p:sp>
         <p:nvSpPr>
-          <p:cNvPr id="19" name="Text 17"/>
+          <p:cNvPr id="20" name="Text 17"/>
           <p:cNvSpPr/>
           <p:nvPr/>
         </p:nvSpPr>
@@ -5293,7 +5293,7 @@
       </p:sp>
       <p:sp>
         <p:nvSpPr>
-          <p:cNvPr id="20" name="Text 18"/>
+          <p:cNvPr id="21" name="Text 18"/>
           <p:cNvSpPr/>
           <p:nvPr/>
         </p:nvSpPr>
@@ -5332,7 +5332,7 @@
       </p:sp>
       <p:sp>
         <p:nvSpPr>
-          <p:cNvPr id="21" name="Shape 19"/>
+          <p:cNvPr id="22" name="Shape 19"/>
           <p:cNvSpPr/>
           <p:nvPr/>
         </p:nvSpPr>
@@ -5364,7 +5364,7 @@
       </p:sp>
       <p:sp>
         <p:nvSpPr>
-          <p:cNvPr id="22" name="Shape 20"/>
+          <p:cNvPr id="23" name="Shape 20"/>
           <p:cNvSpPr/>
           <p:nvPr/>
         </p:nvSpPr>
@@ -5384,7 +5384,7 @@
       </p:sp>
       <p:sp>
         <p:nvSpPr>
-          <p:cNvPr id="23" name="Text 21"/>
+          <p:cNvPr id="24" name="Text 21"/>
           <p:cNvSpPr/>
           <p:nvPr/>
         </p:nvSpPr>
@@ -5426,7 +5426,7 @@
       </p:sp>
       <p:sp>
         <p:nvSpPr>
-          <p:cNvPr id="24" name="Text 22"/>
+          <p:cNvPr id="25" name="Text 22"/>
           <p:cNvSpPr/>
           <p:nvPr/>
         </p:nvSpPr>
@@ -5465,7 +5465,7 @@
       </p:sp>
       <p:sp>
         <p:nvSpPr>
-          <p:cNvPr id="25" name="Shape 23"/>
+          <p:cNvPr id="26" name="Shape 23"/>
           <p:cNvSpPr/>
           <p:nvPr/>
         </p:nvSpPr>
@@ -5497,7 +5497,7 @@
       </p:sp>
       <p:sp>
         <p:nvSpPr>
-          <p:cNvPr id="26" name="Shape 24"/>
+          <p:cNvPr id="27" name="Shape 24"/>
           <p:cNvSpPr/>
           <p:nvPr/>
         </p:nvSpPr>
@@ -5517,7 +5517,7 @@
       </p:sp>
       <p:sp>
         <p:nvSpPr>
-          <p:cNvPr id="27" name="Text 25"/>
+          <p:cNvPr id="28" name="Text 25"/>
           <p:cNvSpPr/>
           <p:nvPr/>
         </p:nvSpPr>
@@ -5559,7 +5559,7 @@
       </p:sp>
       <p:sp>
         <p:nvSpPr>
-          <p:cNvPr id="28" name="Shape 26"/>
+          <p:cNvPr id="29" name="Shape 26"/>
           <p:cNvSpPr/>
           <p:nvPr/>
         </p:nvSpPr>
@@ -5591,7 +5591,7 @@
       </p:sp>
       <p:sp>
         <p:nvSpPr>
-          <p:cNvPr id="29" name="Text 27"/>
+          <p:cNvPr id="30" name="Text 27"/>
           <p:cNvSpPr/>
           <p:nvPr/>
         </p:nvSpPr>
@@ -5644,7 +5644,7 @@
       </p:sp>
       <p:sp>
         <p:nvSpPr>
-          <p:cNvPr id="30" name="Text 28"/>
+          <p:cNvPr id="31" name="Text 28"/>
           <p:cNvSpPr/>
           <p:nvPr/>
         </p:nvSpPr>
@@ -5686,7 +5686,7 @@
       </p:sp>
       <p:sp>
         <p:nvSpPr>
-          <p:cNvPr id="31" name="Text 29"/>
+          <p:cNvPr id="32" name="Text 29"/>
           <p:cNvSpPr/>
           <p:nvPr/>
         </p:nvSpPr>
@@ -5862,7 +5862,7 @@
       </p:grpSpPr>
       <p:sp>
         <p:nvSpPr>
-          <p:cNvPr id="2" name="Shape 0"/>
+          <p:cNvPr id="3" name="Shape 0"/>
           <p:cNvSpPr/>
           <p:nvPr/>
         </p:nvSpPr>
@@ -5882,7 +5882,7 @@
       </p:sp>
       <p:sp>
         <p:nvSpPr>
-          <p:cNvPr id="3" name="Text 1"/>
+          <p:cNvPr id="4" name="Text 1"/>
           <p:cNvSpPr/>
           <p:nvPr/>
         </p:nvSpPr>
@@ -5921,7 +5921,7 @@
       </p:sp>
       <p:sp>
         <p:nvSpPr>
-          <p:cNvPr id="4" name="Text 2"/>
+          <p:cNvPr id="5" name="Text 2"/>
           <p:cNvSpPr/>
           <p:nvPr/>
         </p:nvSpPr>
@@ -5960,7 +5960,7 @@
       </p:sp>
       <p:sp>
         <p:nvSpPr>
-          <p:cNvPr id="5" name="Shape 3"/>
+          <p:cNvPr id="6" name="Shape 3"/>
           <p:cNvSpPr/>
           <p:nvPr/>
         </p:nvSpPr>
@@ -5992,7 +5992,7 @@
       </p:sp>
       <p:sp>
         <p:nvSpPr>
-          <p:cNvPr id="6" name="Shape 4"/>
+          <p:cNvPr id="7" name="Shape 4"/>
           <p:cNvSpPr/>
           <p:nvPr/>
         </p:nvSpPr>
@@ -6012,7 +6012,7 @@
       </p:sp>
       <p:sp>
         <p:nvSpPr>
-          <p:cNvPr id="7" name="Text 5"/>
+          <p:cNvPr id="8" name="Text 5"/>
           <p:cNvSpPr/>
           <p:nvPr/>
         </p:nvSpPr>
@@ -6094,7 +6094,7 @@
       </p:sp>
       <p:sp>
         <p:nvSpPr>
-          <p:cNvPr id="8" name="Text 6"/>
+          <p:cNvPr id="9" name="Text 6"/>
           <p:cNvSpPr/>
           <p:nvPr/>
         </p:nvSpPr>
@@ -6133,7 +6133,7 @@
       </p:sp>
       <p:sp>
         <p:nvSpPr>
-          <p:cNvPr id="9" name="Shape 7"/>
+          <p:cNvPr id="10" name="Shape 7"/>
           <p:cNvSpPr/>
           <p:nvPr/>
         </p:nvSpPr>
@@ -6165,7 +6165,7 @@
       </p:sp>
       <p:sp>
         <p:nvSpPr>
-          <p:cNvPr id="10" name="Shape 8"/>
+          <p:cNvPr id="11" name="Shape 8"/>
           <p:cNvSpPr/>
           <p:nvPr/>
         </p:nvSpPr>
@@ -6185,7 +6185,7 @@
       </p:sp>
       <p:sp>
         <p:nvSpPr>
-          <p:cNvPr id="11" name="Text 9"/>
+          <p:cNvPr id="12" name="Text 9"/>
           <p:cNvSpPr/>
           <p:nvPr/>
         </p:nvSpPr>
@@ -6247,7 +6247,7 @@
       </p:sp>
       <p:sp>
         <p:nvSpPr>
-          <p:cNvPr id="12" name="Text 10"/>
+          <p:cNvPr id="13" name="Text 10"/>
           <p:cNvSpPr/>
           <p:nvPr/>
         </p:nvSpPr>
@@ -6286,7 +6286,7 @@
       </p:sp>
       <p:sp>
         <p:nvSpPr>
-          <p:cNvPr id="13" name="Shape 11"/>
+          <p:cNvPr id="14" name="Shape 11"/>
           <p:cNvSpPr/>
           <p:nvPr/>
         </p:nvSpPr>
@@ -6318,7 +6318,7 @@
       </p:sp>
       <p:sp>
         <p:nvSpPr>
-          <p:cNvPr id="14" name="Shape 12"/>
+          <p:cNvPr id="15" name="Shape 12"/>
           <p:cNvSpPr/>
           <p:nvPr/>
         </p:nvSpPr>
@@ -6338,7 +6338,7 @@
       </p:sp>
       <p:sp>
         <p:nvSpPr>
-          <p:cNvPr id="15" name="Text 13"/>
+          <p:cNvPr id="16" name="Text 13"/>
           <p:cNvSpPr/>
           <p:nvPr/>
         </p:nvSpPr>
@@ -6400,7 +6400,7 @@
       </p:sp>
       <p:sp>
         <p:nvSpPr>
-          <p:cNvPr id="16" name="Text 14"/>
+          <p:cNvPr id="17" name="Text 14"/>
           <p:cNvSpPr/>
           <p:nvPr/>
         </p:nvSpPr>
@@ -6439,7 +6439,7 @@
       </p:sp>
       <p:sp>
         <p:nvSpPr>
-          <p:cNvPr id="17" name="Shape 15"/>
+          <p:cNvPr id="18" name="Shape 15"/>
           <p:cNvSpPr/>
           <p:nvPr/>
         </p:nvSpPr>
@@ -6471,7 +6471,7 @@
       </p:sp>
       <p:sp>
         <p:nvSpPr>
-          <p:cNvPr id="18" name="Shape 16"/>
+          <p:cNvPr id="19" name="Shape 16"/>
           <p:cNvSpPr/>
           <p:nvPr/>
         </p:nvSpPr>
@@ -6491,7 +6491,7 @@
       </p:sp>
       <p:sp>
         <p:nvSpPr>
-          <p:cNvPr id="19" name="Text 17"/>
+          <p:cNvPr id="20" name="Text 17"/>
           <p:cNvSpPr/>
           <p:nvPr/>
         </p:nvSpPr>
@@ -6553,7 +6553,7 @@
       </p:sp>
       <p:sp>
         <p:nvSpPr>
-          <p:cNvPr id="20" name="Text 18"/>
+          <p:cNvPr id="21" name="Text 18"/>
           <p:cNvSpPr/>
           <p:nvPr/>
         </p:nvSpPr>
@@ -6592,7 +6592,7 @@
       </p:sp>
       <p:sp>
         <p:nvSpPr>
-          <p:cNvPr id="21" name="Shape 19"/>
+          <p:cNvPr id="22" name="Shape 19"/>
           <p:cNvSpPr/>
           <p:nvPr/>
         </p:nvSpPr>
@@ -6624,7 +6624,7 @@
       </p:sp>
       <p:sp>
         <p:nvSpPr>
-          <p:cNvPr id="22" name="Shape 20"/>
+          <p:cNvPr id="23" name="Shape 20"/>
           <p:cNvSpPr/>
           <p:nvPr/>
         </p:nvSpPr>
@@ -6644,7 +6644,7 @@
       </p:sp>
       <p:sp>
         <p:nvSpPr>
-          <p:cNvPr id="23" name="Text 21"/>
+          <p:cNvPr id="24" name="Text 21"/>
           <p:cNvSpPr/>
           <p:nvPr/>
         </p:nvSpPr>
@@ -6726,7 +6726,7 @@
       </p:sp>
       <p:sp>
         <p:nvSpPr>
-          <p:cNvPr id="24" name="Shape 22"/>
+          <p:cNvPr id="25" name="Shape 22"/>
           <p:cNvSpPr/>
           <p:nvPr/>
         </p:nvSpPr>
@@ -6758,7 +6758,7 @@
       </p:sp>
       <p:sp>
         <p:nvSpPr>
-          <p:cNvPr id="25" name="Text 23"/>
+          <p:cNvPr id="26" name="Text 23"/>
           <p:cNvSpPr/>
           <p:nvPr/>
         </p:nvSpPr>
@@ -6797,7 +6797,7 @@
       </p:sp>
       <p:sp>
         <p:nvSpPr>
-          <p:cNvPr id="26" name="Text 24"/>
+          <p:cNvPr id="27" name="Text 24"/>
           <p:cNvSpPr/>
           <p:nvPr/>
         </p:nvSpPr>
@@ -6836,7 +6836,7 @@
       </p:sp>
       <p:sp>
         <p:nvSpPr>
-          <p:cNvPr id="27" name="Shape 25"/>
+          <p:cNvPr id="28" name="Shape 25"/>
           <p:cNvSpPr/>
           <p:nvPr/>
         </p:nvSpPr>
@@ -6868,7 +6868,7 @@
       </p:sp>
       <p:sp>
         <p:nvSpPr>
-          <p:cNvPr id="28" name="Text 26"/>
+          <p:cNvPr id="29" name="Text 26"/>
           <p:cNvSpPr/>
           <p:nvPr/>
         </p:nvSpPr>
@@ -6907,7 +6907,7 @@
       </p:sp>
       <p:sp>
         <p:nvSpPr>
-          <p:cNvPr id="29" name="Text 27"/>
+          <p:cNvPr id="30" name="Text 27"/>
           <p:cNvSpPr/>
           <p:nvPr/>
         </p:nvSpPr>
@@ -6946,7 +6946,7 @@
       </p:sp>
       <p:sp>
         <p:nvSpPr>
-          <p:cNvPr id="30" name="Shape 28"/>
+          <p:cNvPr id="31" name="Shape 28"/>
           <p:cNvSpPr/>
           <p:nvPr/>
         </p:nvSpPr>
@@ -6978,7 +6978,7 @@
       </p:sp>
       <p:sp>
         <p:nvSpPr>
-          <p:cNvPr id="31" name="Text 29"/>
+          <p:cNvPr id="32" name="Text 29"/>
           <p:cNvSpPr/>
           <p:nvPr/>
         </p:nvSpPr>
@@ -7017,7 +7017,7 @@
       </p:sp>
       <p:sp>
         <p:nvSpPr>
-          <p:cNvPr id="32" name="Text 30"/>
+          <p:cNvPr id="33" name="Text 30"/>
           <p:cNvSpPr/>
           <p:nvPr/>
         </p:nvSpPr>
@@ -7056,7 +7056,7 @@
       </p:sp>
       <p:sp>
         <p:nvSpPr>
-          <p:cNvPr id="33" name="Shape 31"/>
+          <p:cNvPr id="34" name="Shape 31"/>
           <p:cNvSpPr/>
           <p:nvPr/>
         </p:nvSpPr>
@@ -7088,7 +7088,7 @@
       </p:sp>
       <p:sp>
         <p:nvSpPr>
-          <p:cNvPr id="34" name="Text 32"/>
+          <p:cNvPr id="35" name="Text 32"/>
           <p:cNvSpPr/>
           <p:nvPr/>
         </p:nvSpPr>
@@ -7127,7 +7127,7 @@
       </p:sp>
       <p:sp>
         <p:nvSpPr>
-          <p:cNvPr id="35" name="Text 33"/>
+          <p:cNvPr id="36" name="Text 33"/>
           <p:cNvSpPr/>
           <p:nvPr/>
         </p:nvSpPr>
@@ -7166,7 +7166,7 @@
       </p:sp>
       <p:sp>
         <p:nvSpPr>
-          <p:cNvPr id="36" name="Text 34"/>
+          <p:cNvPr id="37" name="Text 34"/>
           <p:cNvSpPr/>
           <p:nvPr/>
         </p:nvSpPr>
@@ -7205,7 +7205,7 @@
       </p:sp>
       <p:sp>
         <p:nvSpPr>
-          <p:cNvPr id="37" name="Text 35"/>
+          <p:cNvPr id="38" name="Text 35"/>
           <p:cNvSpPr/>
           <p:nvPr/>
         </p:nvSpPr>
@@ -7521,7 +7521,7 @@
       </p:grpSpPr>
       <p:sp>
         <p:nvSpPr>
-          <p:cNvPr id="2" name="Shape 0"/>
+          <p:cNvPr id="3" name="Shape 0"/>
           <p:cNvSpPr/>
           <p:nvPr/>
         </p:nvSpPr>
@@ -7541,7 +7541,7 @@
       </p:sp>
       <p:sp>
         <p:nvSpPr>
-          <p:cNvPr id="3" name="Text 1"/>
+          <p:cNvPr id="4" name="Text 1"/>
           <p:cNvSpPr/>
           <p:nvPr/>
         </p:nvSpPr>
@@ -7580,7 +7580,7 @@
       </p:sp>
       <p:sp>
         <p:nvSpPr>
-          <p:cNvPr id="4" name="Text 2"/>
+          <p:cNvPr id="5" name="Text 2"/>
           <p:cNvSpPr/>
           <p:nvPr/>
         </p:nvSpPr>
@@ -7619,7 +7619,7 @@
       </p:sp>
       <p:sp>
         <p:nvSpPr>
-          <p:cNvPr id="5" name="Shape 3"/>
+          <p:cNvPr id="6" name="Shape 3"/>
           <p:cNvSpPr/>
           <p:nvPr/>
         </p:nvSpPr>
@@ -7651,7 +7651,7 @@
       </p:sp>
       <p:sp>
         <p:nvSpPr>
-          <p:cNvPr id="6" name="Text 4"/>
+          <p:cNvPr id="7" name="Text 4"/>
           <p:cNvSpPr/>
           <p:nvPr/>
         </p:nvSpPr>
@@ -7690,7 +7690,7 @@
       </p:sp>
       <p:sp>
         <p:nvSpPr>
-          <p:cNvPr id="7" name="Text 5"/>
+          <p:cNvPr id="8" name="Text 5"/>
           <p:cNvSpPr/>
           <p:nvPr/>
         </p:nvSpPr>
@@ -7766,7 +7766,7 @@
       </p:sp>
       <p:sp>
         <p:nvSpPr>
-          <p:cNvPr id="8" name="Text 6"/>
+          <p:cNvPr id="9" name="Text 6"/>
           <p:cNvSpPr/>
           <p:nvPr/>
         </p:nvSpPr>
@@ -7805,7 +7805,7 @@
       </p:sp>
       <p:sp>
         <p:nvSpPr>
-          <p:cNvPr id="9" name="Shape 7"/>
+          <p:cNvPr id="10" name="Shape 7"/>
           <p:cNvSpPr/>
           <p:nvPr/>
         </p:nvSpPr>
@@ -7837,7 +7837,7 @@
       </p:sp>
       <p:sp>
         <p:nvSpPr>
-          <p:cNvPr id="10" name="Text 8"/>
+          <p:cNvPr id="11" name="Text 8"/>
           <p:cNvSpPr/>
           <p:nvPr/>
         </p:nvSpPr>
@@ -7876,7 +7876,7 @@
       </p:sp>
       <p:sp>
         <p:nvSpPr>
-          <p:cNvPr id="11" name="Text 9"/>
+          <p:cNvPr id="12" name="Text 9"/>
           <p:cNvSpPr/>
           <p:nvPr/>
         </p:nvSpPr>
@@ -7960,7 +7960,7 @@
       </p:sp>
       <p:sp>
         <p:nvSpPr>
-          <p:cNvPr id="12" name="Text 10"/>
+          <p:cNvPr id="13" name="Text 10"/>
           <p:cNvSpPr/>
           <p:nvPr/>
         </p:nvSpPr>
@@ -8136,7 +8136,7 @@
       </p:grpSpPr>
       <p:sp>
         <p:nvSpPr>
-          <p:cNvPr id="2" name="Shape 0"/>
+          <p:cNvPr id="3" name="Shape 0"/>
           <p:cNvSpPr/>
           <p:nvPr/>
         </p:nvSpPr>
@@ -8156,7 +8156,7 @@
       </p:sp>
       <p:sp>
         <p:nvSpPr>
-          <p:cNvPr id="3" name="Text 1"/>
+          <p:cNvPr id="4" name="Text 1"/>
           <p:cNvSpPr/>
           <p:nvPr/>
         </p:nvSpPr>
@@ -8195,7 +8195,7 @@
       </p:sp>
       <p:sp>
         <p:nvSpPr>
-          <p:cNvPr id="4" name="Text 2"/>
+          <p:cNvPr id="5" name="Text 2"/>
           <p:cNvSpPr/>
           <p:nvPr/>
         </p:nvSpPr>
@@ -8234,7 +8234,7 @@
       </p:sp>
       <p:sp>
         <p:nvSpPr>
-          <p:cNvPr id="5" name="Shape 3"/>
+          <p:cNvPr id="6" name="Shape 3"/>
           <p:cNvSpPr/>
           <p:nvPr/>
         </p:nvSpPr>
@@ -8266,7 +8266,7 @@
       </p:sp>
       <p:sp>
         <p:nvSpPr>
-          <p:cNvPr id="6" name="Shape 4"/>
+          <p:cNvPr id="7" name="Shape 4"/>
           <p:cNvSpPr/>
           <p:nvPr/>
         </p:nvSpPr>
@@ -8286,7 +8286,7 @@
       </p:sp>
       <p:sp>
         <p:nvSpPr>
-          <p:cNvPr id="7" name="Text 5"/>
+          <p:cNvPr id="8" name="Text 5"/>
           <p:cNvSpPr/>
           <p:nvPr/>
         </p:nvSpPr>
@@ -8325,7 +8325,7 @@
       </p:sp>
       <p:sp>
         <p:nvSpPr>
-          <p:cNvPr id="8" name="Text 6"/>
+          <p:cNvPr id="9" name="Text 6"/>
           <p:cNvSpPr/>
           <p:nvPr/>
         </p:nvSpPr>
@@ -8364,7 +8364,7 @@
       </p:sp>
       <p:sp>
         <p:nvSpPr>
-          <p:cNvPr id="9" name="Shape 7"/>
+          <p:cNvPr id="10" name="Shape 7"/>
           <p:cNvSpPr/>
           <p:nvPr/>
         </p:nvSpPr>
@@ -8396,7 +8396,7 @@
       </p:sp>
       <p:sp>
         <p:nvSpPr>
-          <p:cNvPr id="10" name="Shape 8"/>
+          <p:cNvPr id="11" name="Shape 8"/>
           <p:cNvSpPr/>
           <p:nvPr/>
         </p:nvSpPr>
@@ -8416,7 +8416,7 @@
       </p:sp>
       <p:sp>
         <p:nvSpPr>
-          <p:cNvPr id="11" name="Text 9"/>
+          <p:cNvPr id="12" name="Text 9"/>
           <p:cNvSpPr/>
           <p:nvPr/>
         </p:nvSpPr>
@@ -8455,7 +8455,7 @@
       </p:sp>
       <p:sp>
         <p:nvSpPr>
-          <p:cNvPr id="12" name="Text 10"/>
+          <p:cNvPr id="13" name="Text 10"/>
           <p:cNvSpPr/>
           <p:nvPr/>
         </p:nvSpPr>
@@ -8494,7 +8494,7 @@
       </p:sp>
       <p:sp>
         <p:nvSpPr>
-          <p:cNvPr id="13" name="Shape 11"/>
+          <p:cNvPr id="14" name="Shape 11"/>
           <p:cNvSpPr/>
           <p:nvPr/>
         </p:nvSpPr>
@@ -8526,7 +8526,7 @@
       </p:sp>
       <p:sp>
         <p:nvSpPr>
-          <p:cNvPr id="14" name="Text 12"/>
+          <p:cNvPr id="15" name="Text 12"/>
           <p:cNvSpPr/>
           <p:nvPr/>
         </p:nvSpPr>
@@ -8579,7 +8579,7 @@
       </p:sp>
       <p:sp>
         <p:nvSpPr>
-          <p:cNvPr id="15" name="Shape 13"/>
+          <p:cNvPr id="16" name="Shape 13"/>
           <p:cNvSpPr/>
           <p:nvPr/>
         </p:nvSpPr>
@@ -8611,7 +8611,7 @@
       </p:sp>
       <p:sp>
         <p:nvSpPr>
-          <p:cNvPr id="16" name="Text 14"/>
+          <p:cNvPr id="17" name="Text 14"/>
           <p:cNvSpPr/>
           <p:nvPr/>
         </p:nvSpPr>
@@ -8650,7 +8650,7 @@
       </p:sp>
       <p:sp>
         <p:nvSpPr>
-          <p:cNvPr id="17" name="Text 15"/>
+          <p:cNvPr id="18" name="Text 15"/>
           <p:cNvSpPr/>
           <p:nvPr/>
         </p:nvSpPr>

</xml_diff>